<commit_message>
Plantilla etiquetada y script
</commit_message>
<xml_diff>
--- a/Guia_Lista.pptx
+++ b/Guia_Lista.pptx
@@ -6124,7 +6124,7 @@
       </p:sp>
       <p:sp>
         <p:nvSpPr>
-          <p:cNvPr id="55" name="Google Shape;55;p13"/>
+          <p:cNvPr id="55" name="var:Nombre_proceso"/>
           <p:cNvSpPr txBox="1"/>
           <p:nvPr/>
         </p:nvSpPr>
@@ -6157,7 +6157,31 @@
               <a:buNone/>
             </a:pPr>
             <a:r>
-              <a:t>Conciliación Bancaria Mensual</a:t>
+              <a:rPr lang="es-VE" sz="6620" dirty="0">
+                <a:latin typeface="Montserrat ExtraBold"/>
+                <a:ea typeface="Microsoft JhengHei Light" panose="020B0304030504040204" pitchFamily="34" charset="-120"/>
+                <a:cs typeface="Montserrat ExtraBold"/>
+                <a:sym typeface="Montserrat ExtraBold"/>
+              </a:rPr>
+              <a:t/>
+            </a:r>
+            <a:r>
+              <a:rPr lang="es-VE" sz="6620" dirty="0" err="1">
+                <a:latin typeface="Montserrat ExtraBold"/>
+                <a:ea typeface="Microsoft JhengHei Light" panose="020B0304030504040204" pitchFamily="34" charset="-120"/>
+                <a:cs typeface="Montserrat ExtraBold"/>
+                <a:sym typeface="Montserrat ExtraBold"/>
+              </a:rPr>
+              <a:t/>
+            </a:r>
+            <a:r>
+              <a:rPr lang="es-VE" sz="6620" dirty="0">
+                <a:latin typeface="Montserrat ExtraBold"/>
+                <a:ea typeface="Microsoft JhengHei Light" panose="020B0304030504040204" pitchFamily="34" charset="-120"/>
+                <a:cs typeface="Montserrat ExtraBold"/>
+                <a:sym typeface="Montserrat ExtraBold"/>
+              </a:rPr>
+              <a:t/>
             </a:r>
             <a:endParaRPr sz="6620" dirty="0">
               <a:latin typeface="Montserrat ExtraBold"/>
@@ -6226,7 +6250,7 @@
       </p:pic>
       <p:sp>
         <p:nvSpPr>
-          <p:cNvPr id="58" name="Google Shape;58;p13"/>
+          <p:cNvPr id="58" name="var:Fecha_vigencia"/>
           <p:cNvSpPr txBox="1"/>
           <p:nvPr/>
         </p:nvSpPr>
@@ -6262,7 +6286,28 @@
               <a:buNone/>
             </a:pPr>
             <a:r>
-              <a:t>Julio 2026</a:t>
+              <a:rPr lang="es-VE" sz="2388" dirty="0">
+                <a:solidFill>
+                  <a:srgbClr val="4E4F51"/>
+                </a:solidFill>
+                <a:latin typeface="Poppins SemiBold"/>
+                <a:ea typeface="Poppins SemiBold"/>
+                <a:cs typeface="Poppins SemiBold"/>
+                <a:sym typeface="Poppins SemiBold"/>
+              </a:rPr>
+              <a:t/>
+            </a:r>
+            <a:r>
+              <a:rPr lang="en" sz="2388" dirty="0">
+                <a:solidFill>
+                  <a:srgbClr val="4E4F51"/>
+                </a:solidFill>
+                <a:latin typeface="Poppins SemiBold"/>
+                <a:ea typeface="Poppins SemiBold"/>
+                <a:cs typeface="Poppins SemiBold"/>
+                <a:sym typeface="Poppins SemiBold"/>
+              </a:rPr>
+              <a:t/>
             </a:r>
             <a:endParaRPr sz="2388" dirty="0">
               <a:solidFill>
@@ -6278,7 +6323,7 @@
       </p:sp>
       <p:sp>
         <p:nvSpPr>
-          <p:cNvPr id="59" name="Google Shape;59;p13"/>
+          <p:cNvPr id="59" name="var:codigo"/>
           <p:cNvSpPr txBox="1"/>
           <p:nvPr/>
         </p:nvSpPr>
@@ -6319,7 +6364,40 @@
               <a:buNone/>
             </a:pPr>
             <a:r>
+              <a:rPr lang="en" sz="2388" dirty="0">
+                <a:solidFill>
+                  <a:srgbClr val="4E4F51"/>
+                </a:solidFill>
+                <a:latin typeface="Poppins SemiBold"/>
+                <a:ea typeface="Poppins SemiBold"/>
+                <a:cs typeface="Poppins SemiBold"/>
+                <a:sym typeface="Poppins SemiBold"/>
+              </a:rPr>
               <a:t>FIN-001</a:t>
+            </a:r>
+            <a:r>
+              <a:rPr lang="es-VE" sz="2388" dirty="0" err="1">
+                <a:solidFill>
+                  <a:srgbClr val="4E4F51"/>
+                </a:solidFill>
+                <a:latin typeface="Poppins SemiBold"/>
+                <a:ea typeface="Poppins SemiBold"/>
+                <a:cs typeface="Poppins SemiBold"/>
+                <a:sym typeface="Poppins SemiBold"/>
+              </a:rPr>
+              <a:t/>
+            </a:r>
+            <a:r>
+              <a:rPr lang="es-VE" sz="2388" dirty="0">
+                <a:solidFill>
+                  <a:srgbClr val="4E4F51"/>
+                </a:solidFill>
+                <a:latin typeface="Poppins SemiBold"/>
+                <a:ea typeface="Poppins SemiBold"/>
+                <a:cs typeface="Poppins SemiBold"/>
+                <a:sym typeface="Poppins SemiBold"/>
+              </a:rPr>
+              <a:t/>
             </a:r>
             <a:endParaRPr sz="2388" dirty="0">
               <a:solidFill>
@@ -6335,7 +6413,7 @@
       </p:sp>
       <p:sp>
         <p:nvSpPr>
-          <p:cNvPr id="60" name="Google Shape;60;p13"/>
+          <p:cNvPr id="60" name="var:revisión"/>
           <p:cNvSpPr txBox="1"/>
           <p:nvPr/>
         </p:nvSpPr>
@@ -6371,7 +6449,28 @@
               <a:buNone/>
             </a:pPr>
             <a:r>
-              <a:t>Rev. 2</a:t>
+              <a:rPr lang="en" sz="2388" dirty="0">
+                <a:solidFill>
+                  <a:srgbClr val="4E4F51"/>
+                </a:solidFill>
+                <a:latin typeface="Poppins SemiBold"/>
+                <a:ea typeface="Poppins SemiBold"/>
+                <a:cs typeface="Poppins SemiBold"/>
+                <a:sym typeface="Poppins SemiBold"/>
+              </a:rPr>
+              <a:t/>
+            </a:r>
+            <a:r>
+              <a:rPr lang="es-VE" sz="2388" dirty="0">
+                <a:solidFill>
+                  <a:srgbClr val="4E4F51"/>
+                </a:solidFill>
+                <a:latin typeface="Poppins SemiBold"/>
+                <a:ea typeface="Poppins SemiBold"/>
+                <a:cs typeface="Poppins SemiBold"/>
+                <a:sym typeface="Poppins SemiBold"/>
+              </a:rPr>
+              <a:t/>
             </a:r>
             <a:endParaRPr sz="2388" dirty="0">
               <a:solidFill>
@@ -6541,7 +6640,7 @@
       </p:sp>
       <p:sp>
         <p:nvSpPr>
-          <p:cNvPr id="64" name="Google Shape;64;p13"/>
+          <p:cNvPr id="64" name="var:objetivo"/>
           <p:cNvSpPr txBox="1"/>
           <p:nvPr/>
         </p:nvSpPr>
@@ -6582,7 +6681,15 @@
               <a:buNone/>
             </a:pPr>
             <a:r>
-              <a:t>Garantizar la exactitud del saldo en cuentas bancarias frente al libro mayor.</a:t>
+              <a:rPr lang="es-MX" sz="3120" dirty="0">
+                <a:solidFill>
+                  <a:schemeClr val="dk2"/>
+                </a:solidFill>
+                <a:latin typeface="Poppins SemiBold"/>
+                <a:cs typeface="Poppins SemiBold"/>
+                <a:sym typeface="Poppins SemiBold"/>
+              </a:rPr>
+              <a:t>Garantizar la exactitud del saldo en cuentas bancarias.</a:t>
             </a:r>
             <a:endParaRPr sz="5620" dirty="0">
               <a:solidFill>
@@ -6716,7 +6823,7 @@
       </p:sp>
       <p:sp>
         <p:nvSpPr>
-          <p:cNvPr id="67" name="Google Shape;67;p13"/>
+          <p:cNvPr id="67" name="var:norma_1"/>
           <p:cNvSpPr txBox="1"/>
           <p:nvPr/>
         </p:nvSpPr>
@@ -6752,7 +6859,16 @@
               <a:buNone/>
             </a:pPr>
             <a:r>
-              <a:t>No iniciar sin el corte bancario al día 30/31 del mes.</a:t>
+              <a:rPr lang="es-MX" sz="3120" dirty="0">
+                <a:solidFill>
+                  <a:schemeClr val="dk2"/>
+                </a:solidFill>
+                <a:latin typeface="Poppins SemiBold"/>
+                <a:ea typeface="Poppins SemiBold"/>
+                <a:cs typeface="Poppins SemiBold"/>
+                <a:sym typeface="Poppins SemiBold"/>
+              </a:rPr>
+              <a:t>Corte bancario al día 30/31 del mes.</a:t>
             </a:r>
             <a:endParaRPr sz="3120" dirty="0">
               <a:solidFill>
@@ -6768,7 +6884,7 @@
       </p:sp>
       <p:sp>
         <p:nvSpPr>
-          <p:cNvPr id="68" name="Google Shape;68;p13"/>
+          <p:cNvPr id="68" name="var:norma_1"/>
           <p:cNvSpPr/>
           <p:nvPr/>
         </p:nvSpPr>
@@ -6808,7 +6924,7 @@
       </p:sp>
       <p:sp>
         <p:nvSpPr>
-          <p:cNvPr id="69" name="Google Shape;69;p13"/>
+          <p:cNvPr id="69" name="var:norma_2"/>
           <p:cNvSpPr txBox="1"/>
           <p:nvPr/>
         </p:nvSpPr>
@@ -6844,7 +6960,16 @@
               <a:buNone/>
             </a:pPr>
             <a:r>
-              <a:t>Todos los ajustes deben estar aprobados por el supervisor.</a:t>
+              <a:rPr lang="en" sz="3120" dirty="0">
+                <a:solidFill>
+                  <a:schemeClr val="dk2"/>
+                </a:solidFill>
+                <a:latin typeface="Poppins SemiBold"/>
+                <a:ea typeface="Poppins SemiBold"/>
+                <a:cs typeface="Poppins SemiBold"/>
+                <a:sym typeface="Poppins SemiBold"/>
+              </a:rPr>
+              <a:t/>
             </a:r>
             <a:endParaRPr sz="3120" dirty="0">
               <a:solidFill>
@@ -6860,7 +6985,7 @@
       </p:sp>
       <p:sp>
         <p:nvSpPr>
-          <p:cNvPr id="70" name="Google Shape;70;p13"/>
+          <p:cNvPr id="70" name="var:norma_2"/>
           <p:cNvSpPr/>
           <p:nvPr/>
         </p:nvSpPr>
@@ -6900,7 +7025,7 @@
       </p:sp>
       <p:sp>
         <p:nvSpPr>
-          <p:cNvPr id="71" name="Google Shape;71;p13"/>
+          <p:cNvPr id="71" name="var:norma_3"/>
           <p:cNvSpPr txBox="1"/>
           <p:nvPr/>
         </p:nvSpPr>
@@ -6935,6 +7060,18 @@
               </a:spcAft>
               <a:buNone/>
             </a:pPr>
+            <a:r>
+              <a:rPr lang="en" sz="3120" dirty="0">
+                <a:solidFill>
+                  <a:schemeClr val="dk2"/>
+                </a:solidFill>
+                <a:latin typeface="Poppins SemiBold"/>
+                <a:ea typeface="Poppins SemiBold"/>
+                <a:cs typeface="Poppins SemiBold"/>
+                <a:sym typeface="Poppins SemiBold"/>
+              </a:rPr>
+              <a:t/>
+            </a:r>
             <a:endParaRPr sz="3120" dirty="0">
               <a:solidFill>
                 <a:schemeClr val="dk2"/>
@@ -6949,7 +7086,7 @@
       </p:sp>
       <p:sp>
         <p:nvSpPr>
-          <p:cNvPr id="72" name="Google Shape;72;p13"/>
+          <p:cNvPr id="72" name="var:norma_3"/>
           <p:cNvSpPr/>
           <p:nvPr/>
         </p:nvSpPr>
@@ -7098,7 +7235,7 @@
       </p:sp>
       <p:sp>
         <p:nvSpPr>
-          <p:cNvPr id="75" name="Google Shape;75;p13"/>
+          <p:cNvPr id="75" name="var:responsable_1"/>
           <p:cNvSpPr txBox="1"/>
           <p:nvPr/>
         </p:nvSpPr>
@@ -7134,7 +7271,28 @@
               <a:buNone/>
             </a:pPr>
             <a:r>
+              <a:rPr lang="en" sz="3120" dirty="0">
+                <a:solidFill>
+                  <a:schemeClr val="dk2"/>
+                </a:solidFill>
+                <a:latin typeface="Poppins SemiBold"/>
+                <a:ea typeface="Poppins SemiBold"/>
+                <a:cs typeface="Poppins SemiBold"/>
+                <a:sym typeface="Poppins SemiBold"/>
+              </a:rPr>
               <a:t>Analista de Tesorería</a:t>
+            </a:r>
+            <a:r>
+              <a:rPr lang="es-VE" sz="3120" dirty="0">
+                <a:solidFill>
+                  <a:schemeClr val="dk2"/>
+                </a:solidFill>
+                <a:latin typeface="Poppins SemiBold"/>
+                <a:ea typeface="Poppins SemiBold"/>
+                <a:cs typeface="Poppins SemiBold"/>
+                <a:sym typeface="Poppins SemiBold"/>
+              </a:rPr>
+              <a:t/>
             </a:r>
             <a:endParaRPr sz="3120" dirty="0">
               <a:solidFill>
@@ -7150,7 +7308,7 @@
       </p:sp>
       <p:sp>
         <p:nvSpPr>
-          <p:cNvPr id="76" name="Google Shape;76;p13"/>
+          <p:cNvPr id="76" name="var:responsable_1"/>
           <p:cNvSpPr/>
           <p:nvPr/>
         </p:nvSpPr>
@@ -7190,7 +7348,7 @@
       </p:sp>
       <p:sp>
         <p:nvSpPr>
-          <p:cNvPr id="77" name="Google Shape;77;p13"/>
+          <p:cNvPr id="77" name="var:responsable_2"/>
           <p:cNvSpPr txBox="1"/>
           <p:nvPr/>
         </p:nvSpPr>
@@ -7226,7 +7384,28 @@
               <a:buNone/>
             </a:pPr>
             <a:r>
-              <a:t>Coordinador de Contabilidad</a:t>
+              <a:rPr lang="en" sz="3120" dirty="0">
+                <a:solidFill>
+                  <a:schemeClr val="dk2"/>
+                </a:solidFill>
+                <a:latin typeface="Poppins SemiBold"/>
+                <a:ea typeface="Poppins SemiBold"/>
+                <a:cs typeface="Poppins SemiBold"/>
+                <a:sym typeface="Poppins SemiBold"/>
+              </a:rPr>
+              <a:t/>
+            </a:r>
+            <a:r>
+              <a:rPr lang="es-VE" sz="3120" dirty="0">
+                <a:solidFill>
+                  <a:schemeClr val="dk2"/>
+                </a:solidFill>
+                <a:latin typeface="Poppins SemiBold"/>
+                <a:ea typeface="Poppins SemiBold"/>
+                <a:cs typeface="Poppins SemiBold"/>
+                <a:sym typeface="Poppins SemiBold"/>
+              </a:rPr>
+              <a:t/>
             </a:r>
             <a:endParaRPr sz="3120" dirty="0">
               <a:solidFill>
@@ -7242,7 +7421,7 @@
       </p:sp>
       <p:sp>
         <p:nvSpPr>
-          <p:cNvPr id="78" name="Google Shape;78;p13"/>
+          <p:cNvPr id="78" name="var:responsable_2"/>
           <p:cNvSpPr/>
           <p:nvPr/>
         </p:nvSpPr>
@@ -7282,7 +7461,7 @@
       </p:sp>
       <p:sp>
         <p:nvSpPr>
-          <p:cNvPr id="79" name="Google Shape;79;p13"/>
+          <p:cNvPr id="79" name="var:material_1"/>
           <p:cNvSpPr/>
           <p:nvPr/>
         </p:nvSpPr>
@@ -7452,7 +7631,7 @@
       </p:sp>
       <p:sp>
         <p:nvSpPr>
-          <p:cNvPr id="82" name="Google Shape;82;p13"/>
+          <p:cNvPr id="82" name="var:material_1"/>
           <p:cNvSpPr txBox="1"/>
           <p:nvPr/>
         </p:nvSpPr>
@@ -7488,7 +7667,28 @@
               <a:buNone/>
             </a:pPr>
             <a:r>
-              <a:t>Extracto bancario en formato Excel o PDF.</a:t>
+              <a:rPr lang="en" sz="3120" dirty="0">
+                <a:solidFill>
+                  <a:schemeClr val="dk2"/>
+                </a:solidFill>
+                <a:latin typeface="Poppins SemiBold"/>
+                <a:ea typeface="Poppins SemiBold"/>
+                <a:cs typeface="Poppins SemiBold"/>
+                <a:sym typeface="Poppins SemiBold"/>
+              </a:rPr>
+              <a:t>Extracto bancario Excel.</a:t>
+            </a:r>
+            <a:r>
+              <a:rPr lang="es-VE" sz="3120" dirty="0">
+                <a:solidFill>
+                  <a:schemeClr val="dk2"/>
+                </a:solidFill>
+                <a:latin typeface="Poppins SemiBold"/>
+                <a:ea typeface="Poppins SemiBold"/>
+                <a:cs typeface="Poppins SemiBold"/>
+                <a:sym typeface="Poppins SemiBold"/>
+              </a:rPr>
+              <a:t/>
             </a:r>
             <a:endParaRPr sz="3120" dirty="0">
               <a:solidFill>
@@ -7504,7 +7704,7 @@
       </p:sp>
       <p:sp>
         <p:nvSpPr>
-          <p:cNvPr id="83" name="Google Shape;83;p13"/>
+          <p:cNvPr id="83" name="var:material_1"/>
           <p:cNvSpPr/>
           <p:nvPr/>
         </p:nvSpPr>
@@ -7544,7 +7744,7 @@
       </p:sp>
       <p:sp>
         <p:nvSpPr>
-          <p:cNvPr id="84" name="Google Shape;84;p13"/>
+          <p:cNvPr id="84" name="var:material-2"/>
           <p:cNvSpPr txBox="1"/>
           <p:nvPr/>
         </p:nvSpPr>
@@ -7580,7 +7780,28 @@
               <a:buNone/>
             </a:pPr>
             <a:r>
-              <a:t>Reporte auxiliar de bancos exportado de Odoo.</a:t>
+              <a:rPr lang="en" sz="3120" dirty="0">
+                <a:solidFill>
+                  <a:schemeClr val="dk2"/>
+                </a:solidFill>
+                <a:latin typeface="Poppins SemiBold"/>
+                <a:ea typeface="Poppins SemiBold"/>
+                <a:cs typeface="Poppins SemiBold"/>
+                <a:sym typeface="Poppins SemiBold"/>
+              </a:rPr>
+              <a:t/>
+            </a:r>
+            <a:r>
+              <a:rPr lang="es-VE" sz="3120" dirty="0">
+                <a:solidFill>
+                  <a:schemeClr val="dk2"/>
+                </a:solidFill>
+                <a:latin typeface="Poppins SemiBold"/>
+                <a:ea typeface="Poppins SemiBold"/>
+                <a:cs typeface="Poppins SemiBold"/>
+                <a:sym typeface="Poppins SemiBold"/>
+              </a:rPr>
+              <a:t/>
             </a:r>
             <a:endParaRPr sz="3120" dirty="0">
               <a:solidFill>
@@ -7596,7 +7817,7 @@
       </p:sp>
       <p:sp>
         <p:nvSpPr>
-          <p:cNvPr id="85" name="Google Shape;85;p13"/>
+          <p:cNvPr id="85" name="var:material_1"/>
           <p:cNvSpPr/>
           <p:nvPr/>
         </p:nvSpPr>
@@ -7697,7 +7918,7 @@
       </p:sp>
       <p:sp>
         <p:nvSpPr>
-          <p:cNvPr id="87" name="Google Shape;87;p13"/>
+          <p:cNvPr id="87" name="var:equipo_1"/>
           <p:cNvSpPr txBox="1"/>
           <p:nvPr/>
         </p:nvSpPr>
@@ -7733,7 +7954,28 @@
               <a:buNone/>
             </a:pPr>
             <a:r>
-              <a:t>Ninguno requerido.</a:t>
+              <a:rPr lang="es-MX" sz="3120" dirty="0">
+                <a:solidFill>
+                  <a:schemeClr val="dk2"/>
+                </a:solidFill>
+                <a:latin typeface="Poppins SemiBold"/>
+                <a:ea typeface="Poppins SemiBold"/>
+                <a:cs typeface="Poppins SemiBold"/>
+                <a:sym typeface="Poppins SemiBold"/>
+              </a:rPr>
+              <a:t/>
+            </a:r>
+            <a:r>
+              <a:rPr lang="es-VE" sz="3120" dirty="0">
+                <a:solidFill>
+                  <a:schemeClr val="dk2"/>
+                </a:solidFill>
+                <a:latin typeface="Poppins SemiBold"/>
+                <a:ea typeface="Poppins SemiBold"/>
+                <a:cs typeface="Poppins SemiBold"/>
+                <a:sym typeface="Poppins SemiBold"/>
+              </a:rPr>
+              <a:t/>
             </a:r>
             <a:endParaRPr sz="3120" dirty="0">
               <a:solidFill>
@@ -7749,7 +7991,7 @@
       </p:sp>
       <p:sp>
         <p:nvSpPr>
-          <p:cNvPr id="88" name="Google Shape;88;p13"/>
+          <p:cNvPr id="88" name="var:material_1"/>
           <p:cNvSpPr/>
           <p:nvPr/>
         </p:nvSpPr>
@@ -7789,7 +8031,7 @@
       </p:sp>
       <p:sp>
         <p:nvSpPr>
-          <p:cNvPr id="89" name="Google Shape;89;p13"/>
+          <p:cNvPr id="89" name="var:equipo_2"/>
           <p:cNvSpPr txBox="1"/>
           <p:nvPr/>
         </p:nvSpPr>
@@ -7824,6 +8066,30 @@
               </a:spcAft>
               <a:buNone/>
             </a:pPr>
+            <a:r>
+              <a:rPr lang="en" sz="3120" dirty="0">
+                <a:solidFill>
+                  <a:schemeClr val="dk2"/>
+                </a:solidFill>
+                <a:latin typeface="Poppins SemiBold"/>
+                <a:ea typeface="Poppins SemiBold"/>
+                <a:cs typeface="Poppins SemiBold"/>
+                <a:sym typeface="Poppins SemiBold"/>
+              </a:rPr>
+              <a:t/>
+            </a:r>
+            <a:r>
+              <a:rPr lang="es-VE" sz="3120" dirty="0">
+                <a:solidFill>
+                  <a:schemeClr val="dk2"/>
+                </a:solidFill>
+                <a:latin typeface="Poppins SemiBold"/>
+                <a:ea typeface="Poppins SemiBold"/>
+                <a:cs typeface="Poppins SemiBold"/>
+                <a:sym typeface="Poppins SemiBold"/>
+              </a:rPr>
+              <a:t/>
+            </a:r>
             <a:endParaRPr sz="3120" dirty="0">
               <a:solidFill>
                 <a:schemeClr val="dk2"/>
@@ -7838,7 +8104,7 @@
       </p:sp>
       <p:sp>
         <p:nvSpPr>
-          <p:cNvPr id="90" name="Google Shape;90;p13"/>
+          <p:cNvPr id="90" name="var:equipo_2"/>
           <p:cNvSpPr/>
           <p:nvPr/>
         </p:nvSpPr>
@@ -7878,7 +8144,7 @@
       </p:sp>
       <p:sp>
         <p:nvSpPr>
-          <p:cNvPr id="91" name="Google Shape;91;p13"/>
+          <p:cNvPr id="91" name="var:Tip_2"/>
           <p:cNvSpPr/>
           <p:nvPr/>
         </p:nvSpPr>
@@ -7987,7 +8253,7 @@
       </p:sp>
       <p:sp>
         <p:nvSpPr>
-          <p:cNvPr id="93" name="Google Shape;93;p13"/>
+          <p:cNvPr id="93" name="var:tip_1"/>
           <p:cNvSpPr txBox="1"/>
           <p:nvPr/>
         </p:nvSpPr>
@@ -8023,7 +8289,16 @@
               <a:buNone/>
             </a:pPr>
             <a:r>
-              <a:t>Verificar primero las partidas de mayor monto para ganar tiempo.</a:t>
+              <a:rPr lang="es-MX" sz="3120" dirty="0">
+                <a:solidFill>
+                  <a:schemeClr val="dk2"/>
+                </a:solidFill>
+                <a:latin typeface="Poppins SemiBold"/>
+                <a:ea typeface="Poppins SemiBold"/>
+                <a:cs typeface="Poppins SemiBold"/>
+                <a:sym typeface="Poppins SemiBold"/>
+              </a:rPr>
+              <a:t/>
             </a:r>
             <a:endParaRPr sz="3120" dirty="0">
               <a:solidFill>
@@ -8039,7 +8314,7 @@
       </p:sp>
       <p:sp>
         <p:nvSpPr>
-          <p:cNvPr id="94" name="Google Shape;94;p13"/>
+          <p:cNvPr id="94" name="var:tip_1"/>
           <p:cNvSpPr/>
           <p:nvPr/>
         </p:nvSpPr>
@@ -8079,7 +8354,7 @@
       </p:sp>
       <p:sp>
         <p:nvSpPr>
-          <p:cNvPr id="95" name="Google Shape;95;p13"/>
+          <p:cNvPr id="95" name="var:Tip_2"/>
           <p:cNvSpPr txBox="1"/>
           <p:nvPr/>
         </p:nvSpPr>
@@ -8115,7 +8390,16 @@
               <a:buNone/>
             </a:pPr>
             <a:r>
-              <a:t>Utilizar la función BUSCARV para conciliar movimientos masivos.</a:t>
+              <a:rPr lang="es-VE" sz="3120" dirty="0">
+                <a:solidFill>
+                  <a:schemeClr val="dk2"/>
+                </a:solidFill>
+                <a:latin typeface="Poppins SemiBold"/>
+                <a:ea typeface="Poppins SemiBold"/>
+                <a:cs typeface="Poppins SemiBold"/>
+                <a:sym typeface="Poppins SemiBold"/>
+              </a:rPr>
+              <a:t/>
             </a:r>
             <a:endParaRPr sz="3120" dirty="0">
               <a:solidFill>
@@ -8131,7 +8415,7 @@
       </p:sp>
       <p:sp>
         <p:nvSpPr>
-          <p:cNvPr id="96" name="Google Shape;96;p13"/>
+          <p:cNvPr id="96" name="var:tip_3"/>
           <p:cNvSpPr/>
           <p:nvPr/>
         </p:nvSpPr>
@@ -8171,7 +8455,7 @@
       </p:sp>
       <p:sp>
         <p:nvSpPr>
-          <p:cNvPr id="97" name="Google Shape;97;p13"/>
+          <p:cNvPr id="97" name="var:tip_3"/>
           <p:cNvSpPr txBox="1"/>
           <p:nvPr/>
         </p:nvSpPr>
@@ -8206,6 +8490,30 @@
               </a:spcAft>
               <a:buNone/>
             </a:pPr>
+            <a:r>
+              <a:rPr lang="en" sz="3120" dirty="0">
+                <a:solidFill>
+                  <a:schemeClr val="dk2"/>
+                </a:solidFill>
+                <a:latin typeface="Poppins SemiBold"/>
+                <a:ea typeface="Poppins SemiBold"/>
+                <a:cs typeface="Poppins SemiBold"/>
+                <a:sym typeface="Poppins SemiBold"/>
+              </a:rPr>
+              <a:t/>
+            </a:r>
+            <a:r>
+              <a:rPr lang="es-VE" sz="3120" dirty="0">
+                <a:solidFill>
+                  <a:schemeClr val="dk2"/>
+                </a:solidFill>
+                <a:latin typeface="Poppins SemiBold"/>
+                <a:ea typeface="Poppins SemiBold"/>
+                <a:cs typeface="Poppins SemiBold"/>
+                <a:sym typeface="Poppins SemiBold"/>
+              </a:rPr>
+              <a:t/>
+            </a:r>
             <a:endParaRPr sz="3120" dirty="0">
               <a:solidFill>
                 <a:schemeClr val="dk2"/>
@@ -8220,7 +8528,7 @@
       </p:sp>
       <p:sp>
         <p:nvSpPr>
-          <p:cNvPr id="98" name="Google Shape;98;p13"/>
+          <p:cNvPr id="98" name="var:tip_3"/>
           <p:cNvSpPr/>
           <p:nvPr/>
         </p:nvSpPr>
@@ -8385,7 +8693,7 @@
       </p:sp>
       <p:sp>
         <p:nvSpPr>
-          <p:cNvPr id="49" name="Google Shape;59;p13">
+          <p:cNvPr id="49" name="var:tiempo_ejecucion">
             <a:extLst>
               <a:ext uri="{FF2B5EF4-FFF2-40B4-BE49-F238E27FC236}">
                 <a16:creationId xmlns:a16="http://schemas.microsoft.com/office/drawing/2014/main" id="{49D06808-E569-47F6-9328-721440970DAE}"/>
@@ -8432,7 +8740,40 @@
               <a:buNone/>
             </a:pPr>
             <a:r>
-              <a:t>2 a 3 horas por cuenta</a:t>
+              <a:rPr lang="en" sz="2388" dirty="0">
+                <a:solidFill>
+                  <a:srgbClr val="4E4F51"/>
+                </a:solidFill>
+                <a:latin typeface="Poppins SemiBold"/>
+                <a:ea typeface="Poppins SemiBold"/>
+                <a:cs typeface="Poppins SemiBold"/>
+                <a:sym typeface="Poppins SemiBold"/>
+              </a:rPr>
+              <a:t>2 horas</a:t>
+            </a:r>
+            <a:r>
+              <a:rPr lang="es-VE" sz="2388" dirty="0" err="1">
+                <a:solidFill>
+                  <a:srgbClr val="4E4F51"/>
+                </a:solidFill>
+                <a:latin typeface="Poppins SemiBold"/>
+                <a:ea typeface="Poppins SemiBold"/>
+                <a:cs typeface="Poppins SemiBold"/>
+                <a:sym typeface="Poppins SemiBold"/>
+              </a:rPr>
+              <a:t/>
+            </a:r>
+            <a:r>
+              <a:rPr lang="es-VE" sz="2388" dirty="0">
+                <a:solidFill>
+                  <a:srgbClr val="4E4F51"/>
+                </a:solidFill>
+                <a:latin typeface="Poppins SemiBold"/>
+                <a:ea typeface="Poppins SemiBold"/>
+                <a:cs typeface="Poppins SemiBold"/>
+                <a:sym typeface="Poppins SemiBold"/>
+              </a:rPr>
+              <a:t/>
             </a:r>
             <a:endParaRPr sz="2388" dirty="0">
               <a:solidFill>
@@ -8481,7 +8822,7 @@
       </p:grpSpPr>
       <p:sp>
         <p:nvSpPr>
-          <p:cNvPr id="103" name="Google Shape;103;p14"/>
+          <p:cNvPr id="103" name="var:descripcion_paso_2"/>
           <p:cNvSpPr/>
           <p:nvPr/>
         </p:nvSpPr>
@@ -8527,7 +8868,7 @@
       </p:sp>
       <p:sp>
         <p:nvSpPr>
-          <p:cNvPr id="104" name="Google Shape;104;p14"/>
+          <p:cNvPr id="104" name="var:descripcion_paso_1"/>
           <p:cNvSpPr/>
           <p:nvPr/>
         </p:nvSpPr>
@@ -8682,7 +9023,7 @@
       </p:sp>
       <p:sp>
         <p:nvSpPr>
-          <p:cNvPr id="107" name="Google Shape;107;p14"/>
+          <p:cNvPr id="107" name="var:titulo_conocimiento_1"/>
           <p:cNvSpPr/>
           <p:nvPr/>
         </p:nvSpPr>
@@ -8722,7 +9063,7 @@
       </p:sp>
       <p:sp>
         <p:nvSpPr>
-          <p:cNvPr id="108" name="Google Shape;108;p14"/>
+          <p:cNvPr id="108" name="var:titulo_conocimiento_1"/>
           <p:cNvSpPr txBox="1"/>
           <p:nvPr/>
         </p:nvSpPr>
@@ -8758,7 +9099,28 @@
               <a:buNone/>
             </a:pPr>
             <a:r>
-              <a:t>Manejo de Odoo</a:t>
+              <a:rPr lang="en" sz="3800" dirty="0">
+                <a:solidFill>
+                  <a:srgbClr val="F26F33"/>
+                </a:solidFill>
+                <a:latin typeface="Montserrat ExtraBold"/>
+                <a:ea typeface="Montserrat ExtraBold"/>
+                <a:cs typeface="Montserrat ExtraBold"/>
+                <a:sym typeface="Montserrat ExtraBold"/>
+              </a:rPr>
+              <a:t/>
+            </a:r>
+            <a:r>
+              <a:rPr lang="es-VE" sz="3800" dirty="0">
+                <a:solidFill>
+                  <a:srgbClr val="F26F33"/>
+                </a:solidFill>
+                <a:latin typeface="Montserrat ExtraBold"/>
+                <a:ea typeface="Montserrat ExtraBold"/>
+                <a:cs typeface="Montserrat ExtraBold"/>
+                <a:sym typeface="Montserrat ExtraBold"/>
+              </a:rPr>
+              <a:t/>
             </a:r>
             <a:endParaRPr sz="3800" dirty="0">
               <a:solidFill>
@@ -8774,7 +9136,7 @@
       </p:sp>
       <p:sp>
         <p:nvSpPr>
-          <p:cNvPr id="109" name="Google Shape;109;p14"/>
+          <p:cNvPr id="109" name="var:texto_conocimiento_1"/>
           <p:cNvSpPr txBox="1"/>
           <p:nvPr/>
         </p:nvSpPr>
@@ -8810,7 +9172,28 @@
               <a:buNone/>
             </a:pPr>
             <a:r>
-              <a:t>Saber exportar libros auxiliares e identificar asientos.</a:t>
+              <a:rPr lang="en" sz="3120" dirty="0">
+                <a:solidFill>
+                  <a:schemeClr val="dk2"/>
+                </a:solidFill>
+                <a:latin typeface="Poppins SemiBold"/>
+                <a:ea typeface="Poppins SemiBold"/>
+                <a:cs typeface="Poppins SemiBold"/>
+                <a:sym typeface="Poppins SemiBold"/>
+              </a:rPr>
+              <a:t/>
+            </a:r>
+            <a:r>
+              <a:rPr lang="es-VE" sz="3120" dirty="0">
+                <a:solidFill>
+                  <a:schemeClr val="dk2"/>
+                </a:solidFill>
+                <a:latin typeface="Poppins SemiBold"/>
+                <a:ea typeface="Poppins SemiBold"/>
+                <a:cs typeface="Poppins SemiBold"/>
+                <a:sym typeface="Poppins SemiBold"/>
+              </a:rPr>
+              <a:t/>
             </a:r>
             <a:endParaRPr sz="3120" dirty="0">
               <a:solidFill>
@@ -8826,7 +9209,7 @@
       </p:sp>
       <p:sp>
         <p:nvSpPr>
-          <p:cNvPr id="110" name="Google Shape;110;p14"/>
+          <p:cNvPr id="110" name="var:titulo_conocimiento_2"/>
           <p:cNvSpPr/>
           <p:nvPr/>
         </p:nvSpPr>
@@ -8866,7 +9249,7 @@
       </p:sp>
       <p:sp>
         <p:nvSpPr>
-          <p:cNvPr id="111" name="Google Shape;111;p14"/>
+          <p:cNvPr id="111" name="var:titulo_conocimiento_2"/>
           <p:cNvSpPr txBox="1"/>
           <p:nvPr/>
         </p:nvSpPr>
@@ -8902,7 +9285,28 @@
               <a:buNone/>
             </a:pPr>
             <a:r>
-              <a:t>Excel Intermedio</a:t>
+              <a:rPr lang="en" sz="3800" dirty="0">
+                <a:solidFill>
+                  <a:srgbClr val="F26F33"/>
+                </a:solidFill>
+                <a:latin typeface="Montserrat ExtraBold"/>
+                <a:ea typeface="Montserrat ExtraBold"/>
+                <a:cs typeface="Montserrat ExtraBold"/>
+                <a:sym typeface="Montserrat ExtraBold"/>
+              </a:rPr>
+              <a:t/>
+            </a:r>
+            <a:r>
+              <a:rPr lang="es-VE" sz="3800" dirty="0">
+                <a:solidFill>
+                  <a:srgbClr val="F26F33"/>
+                </a:solidFill>
+                <a:latin typeface="Montserrat ExtraBold"/>
+                <a:ea typeface="Montserrat ExtraBold"/>
+                <a:cs typeface="Montserrat ExtraBold"/>
+                <a:sym typeface="Montserrat ExtraBold"/>
+              </a:rPr>
+              <a:t/>
             </a:r>
             <a:endParaRPr sz="3800" dirty="0">
               <a:solidFill>
@@ -8918,7 +9322,7 @@
       </p:sp>
       <p:sp>
         <p:nvSpPr>
-          <p:cNvPr id="112" name="Google Shape;112;p14"/>
+          <p:cNvPr id="112" name="var:texto_conocimiento_2"/>
           <p:cNvSpPr txBox="1"/>
           <p:nvPr/>
         </p:nvSpPr>
@@ -8954,7 +9358,28 @@
               <a:buNone/>
             </a:pPr>
             <a:r>
-              <a:t>Dominio de tablas dinámicas y filtros avanzados.</a:t>
+              <a:rPr lang="en" sz="3120" dirty="0">
+                <a:solidFill>
+                  <a:schemeClr val="dk2"/>
+                </a:solidFill>
+                <a:latin typeface="Poppins SemiBold"/>
+                <a:ea typeface="Poppins SemiBold"/>
+                <a:cs typeface="Poppins SemiBold"/>
+                <a:sym typeface="Poppins SemiBold"/>
+              </a:rPr>
+              <a:t/>
+            </a:r>
+            <a:r>
+              <a:rPr lang="es-VE" sz="3120" dirty="0">
+                <a:solidFill>
+                  <a:schemeClr val="dk2"/>
+                </a:solidFill>
+                <a:latin typeface="Poppins SemiBold"/>
+                <a:ea typeface="Poppins SemiBold"/>
+                <a:cs typeface="Poppins SemiBold"/>
+                <a:sym typeface="Poppins SemiBold"/>
+              </a:rPr>
+              <a:t/>
             </a:r>
             <a:endParaRPr sz="3120" dirty="0">
               <a:solidFill>
@@ -8970,7 +9395,7 @@
       </p:sp>
       <p:sp>
         <p:nvSpPr>
-          <p:cNvPr id="113" name="Google Shape;113;p14"/>
+          <p:cNvPr id="113" name="var:titulo_conocimiento_3"/>
           <p:cNvSpPr/>
           <p:nvPr/>
         </p:nvSpPr>
@@ -9010,7 +9435,7 @@
       </p:sp>
       <p:sp>
         <p:nvSpPr>
-          <p:cNvPr id="114" name="Google Shape;114;p14"/>
+          <p:cNvPr id="114" name="var:titulo_conocimiento_3"/>
           <p:cNvSpPr txBox="1"/>
           <p:nvPr/>
         </p:nvSpPr>
@@ -9045,6 +9470,18 @@
               </a:spcAft>
               <a:buNone/>
             </a:pPr>
+            <a:r>
+              <a:rPr lang="es-MX" sz="3800" dirty="0">
+                <a:solidFill>
+                  <a:srgbClr val="F26F33"/>
+                </a:solidFill>
+                <a:latin typeface="Montserrat ExtraBold"/>
+                <a:ea typeface="Montserrat ExtraBold"/>
+                <a:cs typeface="Montserrat ExtraBold"/>
+                <a:sym typeface="Montserrat ExtraBold"/>
+              </a:rPr>
+              <a:t/>
+            </a:r>
             <a:endParaRPr sz="3800" dirty="0">
               <a:solidFill>
                 <a:srgbClr val="F26F33"/>
@@ -9059,7 +9496,7 @@
       </p:sp>
       <p:sp>
         <p:nvSpPr>
-          <p:cNvPr id="115" name="Google Shape;115;p14"/>
+          <p:cNvPr id="115" name="var:texto_conocimiento_3"/>
           <p:cNvSpPr txBox="1"/>
           <p:nvPr/>
         </p:nvSpPr>
@@ -9094,6 +9531,30 @@
               </a:spcAft>
               <a:buNone/>
             </a:pPr>
+            <a:r>
+              <a:rPr lang="en" sz="3120" dirty="0">
+                <a:solidFill>
+                  <a:schemeClr val="dk2"/>
+                </a:solidFill>
+                <a:latin typeface="Poppins SemiBold"/>
+                <a:ea typeface="Poppins SemiBold"/>
+                <a:cs typeface="Poppins SemiBold"/>
+                <a:sym typeface="Poppins SemiBold"/>
+              </a:rPr>
+              <a:t/>
+            </a:r>
+            <a:r>
+              <a:rPr lang="es-VE" sz="3120" dirty="0">
+                <a:solidFill>
+                  <a:schemeClr val="dk2"/>
+                </a:solidFill>
+                <a:latin typeface="Poppins SemiBold"/>
+                <a:ea typeface="Poppins SemiBold"/>
+                <a:cs typeface="Poppins SemiBold"/>
+                <a:sym typeface="Poppins SemiBold"/>
+              </a:rPr>
+              <a:t/>
+            </a:r>
             <a:endParaRPr sz="3120" dirty="0">
               <a:solidFill>
                 <a:schemeClr val="dk2"/>
@@ -9278,7 +9739,7 @@
       </p:sp>
       <p:sp>
         <p:nvSpPr>
-          <p:cNvPr id="120" name="Google Shape;120;p14"/>
+          <p:cNvPr id="120" name="var:contexto_operativo"/>
           <p:cNvSpPr txBox="1"/>
           <p:nvPr/>
         </p:nvSpPr>
@@ -9319,7 +9780,40 @@
               <a:buNone/>
             </a:pPr>
             <a:r>
-              <a:t>Proceso crítico de cierre mensual en el área de finanzas.</a:t>
+              <a:rPr lang="es-MX" sz="3120" dirty="0">
+                <a:solidFill>
+                  <a:schemeClr val="dk2"/>
+                </a:solidFill>
+                <a:latin typeface="Poppins SemiBold"/>
+                <a:ea typeface="Poppins SemiBold"/>
+                <a:cs typeface="Poppins SemiBold"/>
+                <a:sym typeface="Poppins SemiBold"/>
+              </a:rPr>
+              <a:t>Cierre mensual.</a:t>
+            </a:r>
+            <a:r>
+              <a:rPr lang="es-MX" sz="3120" dirty="0" err="1">
+                <a:solidFill>
+                  <a:schemeClr val="dk2"/>
+                </a:solidFill>
+                <a:latin typeface="Poppins SemiBold"/>
+                <a:ea typeface="Poppins SemiBold"/>
+                <a:cs typeface="Poppins SemiBold"/>
+                <a:sym typeface="Poppins SemiBold"/>
+              </a:rPr>
+              <a:t/>
+            </a:r>
+            <a:r>
+              <a:rPr lang="es-MX" sz="3120" dirty="0">
+                <a:solidFill>
+                  <a:schemeClr val="dk2"/>
+                </a:solidFill>
+                <a:latin typeface="Poppins SemiBold"/>
+                <a:ea typeface="Poppins SemiBold"/>
+                <a:cs typeface="Poppins SemiBold"/>
+                <a:sym typeface="Poppins SemiBold"/>
+              </a:rPr>
+              <a:t/>
             </a:r>
             <a:endParaRPr sz="3120" dirty="0">
               <a:solidFill>
@@ -9375,7 +9869,7 @@
       </p:sp>
       <p:pic>
         <p:nvPicPr>
-          <p:cNvPr id="122" name="Google Shape;122;p14" title="paso.png"/>
+          <p:cNvPr id="122" name="var:descripcion_paso_1" title="paso.png"/>
           <p:cNvPicPr preferRelativeResize="0"/>
           <p:nvPr/>
         </p:nvPicPr>
@@ -9403,7 +9897,7 @@
       </p:pic>
       <p:sp>
         <p:nvSpPr>
-          <p:cNvPr id="123" name="Google Shape;123;p14"/>
+          <p:cNvPr id="123" name="var:descripcion_paso_1"/>
           <p:cNvSpPr txBox="1"/>
           <p:nvPr/>
         </p:nvSpPr>
@@ -9461,7 +9955,7 @@
       </p:sp>
       <p:pic>
         <p:nvPicPr>
-          <p:cNvPr id="124" name="Google Shape;124;p14" title="paso.png"/>
+          <p:cNvPr id="124" name="var:descripcion_paso_2" title="paso.png"/>
           <p:cNvPicPr preferRelativeResize="0"/>
           <p:nvPr/>
         </p:nvPicPr>
@@ -9489,7 +9983,7 @@
       </p:pic>
       <p:sp>
         <p:nvSpPr>
-          <p:cNvPr id="125" name="Google Shape;125;p14"/>
+          <p:cNvPr id="125" name="var:descripcion_paso_2"/>
           <p:cNvSpPr txBox="1"/>
           <p:nvPr/>
         </p:nvSpPr>
@@ -9547,7 +10041,7 @@
       </p:sp>
       <p:sp>
         <p:nvSpPr>
-          <p:cNvPr id="126" name="Google Shape;126;p14"/>
+          <p:cNvPr id="126" name="var:descripcion_paso_1"/>
           <p:cNvSpPr txBox="1"/>
           <p:nvPr/>
         </p:nvSpPr>
@@ -9583,7 +10077,16 @@
               <a:buNone/>
             </a:pPr>
             <a:r>
-              <a:t>Ingresar al portal bancario con credenciales de lectura y descargar el estado de cuenta.</a:t>
+              <a:rPr lang="es-MX" sz="3120" dirty="0">
+                <a:solidFill>
+                  <a:schemeClr val="dk2"/>
+                </a:solidFill>
+                <a:latin typeface="Poppins SemiBold"/>
+                <a:ea typeface="Poppins SemiBold"/>
+                <a:cs typeface="Poppins SemiBold"/>
+                <a:sym typeface="Poppins SemiBold"/>
+              </a:rPr>
+              <a:t>Descargar estado de cuenta.</a:t>
             </a:r>
             <a:endParaRPr sz="3120" dirty="0">
               <a:solidFill>
@@ -9599,7 +10102,7 @@
       </p:sp>
       <p:sp>
         <p:nvSpPr>
-          <p:cNvPr id="127" name="Google Shape;127;p14"/>
+          <p:cNvPr id="127" name="var:descripcion_paso_2"/>
           <p:cNvSpPr txBox="1"/>
           <p:nvPr/>
         </p:nvSpPr>
@@ -9635,7 +10138,16 @@
               <a:buNone/>
             </a:pPr>
             <a:r>
-              <a:t>Importar el extracto en el módulo contable y ejecutar el cruce automático.</a:t>
+              <a:rPr lang="es-MX" sz="3120" dirty="0">
+                <a:solidFill>
+                  <a:schemeClr val="dk2"/>
+                </a:solidFill>
+                <a:latin typeface="Poppins SemiBold"/>
+                <a:ea typeface="Poppins SemiBold"/>
+                <a:cs typeface="Poppins SemiBold"/>
+                <a:sym typeface="Poppins SemiBold"/>
+              </a:rPr>
+              <a:t>Importar en el módulo contable.</a:t>
             </a:r>
             <a:endParaRPr sz="3120" dirty="0">
               <a:solidFill>
@@ -9651,7 +10163,7 @@
       </p:sp>
       <p:sp>
         <p:nvSpPr>
-          <p:cNvPr id="128" name="Google Shape;128;p14"/>
+          <p:cNvPr id="128" name="var:descripcion_paso_1"/>
           <p:cNvSpPr/>
           <p:nvPr/>
         </p:nvSpPr>
@@ -9719,7 +10231,7 @@
       </p:sp>
       <p:sp>
         <p:nvSpPr>
-          <p:cNvPr id="129" name="Google Shape;129;p14"/>
+          <p:cNvPr id="129" name="var:descripcion_paso_1"/>
           <p:cNvSpPr/>
           <p:nvPr/>
         </p:nvSpPr>
@@ -9787,7 +10299,7 @@
       </p:sp>
       <p:sp>
         <p:nvSpPr>
-          <p:cNvPr id="130" name="Google Shape;130;p14"/>
+          <p:cNvPr id="130" name="var:descripcion_paso_2"/>
           <p:cNvSpPr/>
           <p:nvPr/>
         </p:nvSpPr>
@@ -9888,7 +10400,7 @@
       </p:grpSpPr>
       <p:sp>
         <p:nvSpPr>
-          <p:cNvPr id="135" name="Google Shape;135;p15"/>
+          <p:cNvPr id="135" name="var:descripcion_paso_4"/>
           <p:cNvSpPr/>
           <p:nvPr/>
         </p:nvSpPr>
@@ -9934,7 +10446,7 @@
       </p:sp>
       <p:sp>
         <p:nvSpPr>
-          <p:cNvPr id="136" name="Google Shape;136;p15"/>
+          <p:cNvPr id="136" name="var:descripcion_paso_3"/>
           <p:cNvSpPr/>
           <p:nvPr/>
         </p:nvSpPr>
@@ -10020,7 +10532,7 @@
       </p:sp>
       <p:pic>
         <p:nvPicPr>
-          <p:cNvPr id="138" name="Google Shape;138;p15" title="paso.png"/>
+          <p:cNvPr id="138" name="var:descripcion_paso_3" title="paso.png"/>
           <p:cNvPicPr preferRelativeResize="0"/>
           <p:nvPr/>
         </p:nvPicPr>
@@ -10048,7 +10560,7 @@
       </p:pic>
       <p:sp>
         <p:nvSpPr>
-          <p:cNvPr id="139" name="Google Shape;139;p15"/>
+          <p:cNvPr id="139" name="var:descripcion_paso_3"/>
           <p:cNvSpPr txBox="1"/>
           <p:nvPr/>
         </p:nvSpPr>
@@ -10106,7 +10618,7 @@
       </p:sp>
       <p:pic>
         <p:nvPicPr>
-          <p:cNvPr id="140" name="Google Shape;140;p15" title="paso.png"/>
+          <p:cNvPr id="140" name="var:descripcion_paso_4" title="paso.png"/>
           <p:cNvPicPr preferRelativeResize="0"/>
           <p:nvPr/>
         </p:nvPicPr>
@@ -10134,7 +10646,7 @@
       </p:pic>
       <p:sp>
         <p:nvSpPr>
-          <p:cNvPr id="141" name="Google Shape;141;p15"/>
+          <p:cNvPr id="141" name="var:descripcion_paso_4"/>
           <p:cNvSpPr txBox="1"/>
           <p:nvPr/>
         </p:nvSpPr>
@@ -10192,7 +10704,7 @@
       </p:sp>
       <p:sp>
         <p:nvSpPr>
-          <p:cNvPr id="142" name="Google Shape;142;p15"/>
+          <p:cNvPr id="142" name="var:descripcion_paso_3"/>
           <p:cNvSpPr txBox="1"/>
           <p:nvPr/>
         </p:nvSpPr>
@@ -10233,7 +10745,16 @@
               <a:buNone/>
             </a:pPr>
             <a:r>
-              <a:t>Identificar las partidas conciliadas y marcar los movimientos en tránsito.</a:t>
+              <a:rPr lang="es-MX" sz="3120" dirty="0">
+                <a:solidFill>
+                  <a:schemeClr val="dk2"/>
+                </a:solidFill>
+                <a:latin typeface="Poppins SemiBold"/>
+                <a:ea typeface="Poppins SemiBold"/>
+                <a:cs typeface="Poppins SemiBold"/>
+                <a:sym typeface="Poppins SemiBold"/>
+              </a:rPr>
+              <a:t>Identificar partidas conciliadas.</a:t>
             </a:r>
             <a:endParaRPr sz="3120" dirty="0">
               <a:solidFill>
@@ -10249,7 +10770,7 @@
       </p:sp>
       <p:sp>
         <p:nvSpPr>
-          <p:cNvPr id="143" name="Google Shape;143;p15"/>
+          <p:cNvPr id="143" name="var:descripcion_paso_4"/>
           <p:cNvSpPr txBox="1"/>
           <p:nvPr/>
         </p:nvSpPr>
@@ -10285,7 +10806,16 @@
               <a:buNone/>
             </a:pPr>
             <a:r>
-              <a:t>Elaborar el reporte de diferencias y enviarlo para revisión.</a:t>
+              <a:rPr lang="es-MX" sz="3120" dirty="0">
+                <a:solidFill>
+                  <a:schemeClr val="dk2"/>
+                </a:solidFill>
+                <a:latin typeface="Poppins SemiBold"/>
+                <a:ea typeface="Poppins SemiBold"/>
+                <a:cs typeface="Poppins SemiBold"/>
+                <a:sym typeface="Poppins SemiBold"/>
+              </a:rPr>
+              <a:t>Elaborar reporte de diferencias.</a:t>
             </a:r>
             <a:endParaRPr sz="3120" dirty="0">
               <a:solidFill>
@@ -10301,7 +10831,7 @@
       </p:sp>
       <p:sp>
         <p:nvSpPr>
-          <p:cNvPr id="144" name="Google Shape;144;p15"/>
+          <p:cNvPr id="144" name="var:descripcion_paso_6"/>
           <p:cNvSpPr/>
           <p:nvPr/>
         </p:nvSpPr>
@@ -10347,7 +10877,7 @@
       </p:sp>
       <p:sp>
         <p:nvSpPr>
-          <p:cNvPr id="145" name="Google Shape;145;p15"/>
+          <p:cNvPr id="145" name="var:descripcion_paso_5"/>
           <p:cNvSpPr/>
           <p:nvPr/>
         </p:nvSpPr>
@@ -10393,7 +10923,7 @@
       </p:sp>
       <p:pic>
         <p:nvPicPr>
-          <p:cNvPr id="146" name="Google Shape;146;p15" title="paso.png"/>
+          <p:cNvPr id="146" name="var:descripcion_paso_5" title="paso.png"/>
           <p:cNvPicPr preferRelativeResize="0"/>
           <p:nvPr/>
         </p:nvPicPr>
@@ -10421,7 +10951,7 @@
       </p:pic>
       <p:sp>
         <p:nvSpPr>
-          <p:cNvPr id="147" name="Google Shape;147;p15"/>
+          <p:cNvPr id="147" name="var:descripcion_paso_5"/>
           <p:cNvSpPr txBox="1"/>
           <p:nvPr/>
         </p:nvSpPr>
@@ -10479,7 +11009,7 @@
       </p:sp>
       <p:pic>
         <p:nvPicPr>
-          <p:cNvPr id="148" name="Google Shape;148;p15" title="paso.png"/>
+          <p:cNvPr id="148" name="var:descripcion_paso_6" title="paso.png"/>
           <p:cNvPicPr preferRelativeResize="0"/>
           <p:nvPr/>
         </p:nvPicPr>
@@ -10507,14 +11037,14 @@
       </p:pic>
       <p:sp>
         <p:nvSpPr>
-          <p:cNvPr id="149" name="Google Shape;149;p15"/>
+          <p:cNvPr id="150" name="var:descripcion_paso_5"/>
           <p:cNvSpPr txBox="1"/>
           <p:nvPr/>
         </p:nvSpPr>
         <p:spPr>
           <a:xfrm>
-            <a:off x="1572941" y="16219710"/>
-            <a:ext cx="1532400" cy="2876400"/>
+            <a:off x="4158375" y="12640274"/>
+            <a:ext cx="8073600" cy="664767"/>
           </a:xfrm>
           <a:prstGeom prst="rect">
             <a:avLst/>
@@ -10525,64 +11055,6 @@
           </a:ln>
         </p:spPr>
         <p:txBody>
-          <a:bodyPr spcFirstLastPara="1" wrap="square" lIns="80600" tIns="80600" rIns="80600" bIns="80600" anchor="t" anchorCtr="0">
-            <a:spAutoFit/>
-          </a:bodyPr>
-          <a:lstStyle/>
-          <a:p>
-            <a:pPr marL="0" lvl="0" indent="0" algn="ctr" rtl="0">
-              <a:spcBef>
-                <a:spcPts val="0"/>
-              </a:spcBef>
-              <a:spcAft>
-                <a:spcPts val="0"/>
-              </a:spcAft>
-              <a:buNone/>
-            </a:pPr>
-            <a:r>
-              <a:rPr lang="en" sz="17629">
-                <a:solidFill>
-                  <a:srgbClr val="FFF0E6"/>
-                </a:solidFill>
-                <a:latin typeface="Montserrat ExtraBold"/>
-                <a:ea typeface="Montserrat ExtraBold"/>
-                <a:cs typeface="Montserrat ExtraBold"/>
-                <a:sym typeface="Montserrat ExtraBold"/>
-              </a:rPr>
-              <a:t>6</a:t>
-            </a:r>
-            <a:endParaRPr sz="17629">
-              <a:solidFill>
-                <a:srgbClr val="FFF0E6"/>
-              </a:solidFill>
-              <a:latin typeface="Montserrat ExtraBold"/>
-              <a:ea typeface="Montserrat ExtraBold"/>
-              <a:cs typeface="Montserrat ExtraBold"/>
-              <a:sym typeface="Montserrat ExtraBold"/>
-            </a:endParaRPr>
-          </a:p>
-        </p:txBody>
-      </p:sp>
-      <p:sp>
-        <p:nvSpPr>
-          <p:cNvPr id="150" name="Google Shape;150;p15"/>
-          <p:cNvSpPr txBox="1"/>
-          <p:nvPr/>
-        </p:nvSpPr>
-        <p:spPr>
-          <a:xfrm>
-            <a:off x="4158375" y="12640274"/>
-            <a:ext cx="8073600" cy="664767"/>
-          </a:xfrm>
-          <a:prstGeom prst="rect">
-            <a:avLst/>
-          </a:prstGeom>
-          <a:noFill/>
-          <a:ln>
-            <a:noFill/>
-          </a:ln>
-        </p:spPr>
-        <p:txBody>
           <a:bodyPr spcFirstLastPara="1" wrap="square" lIns="91425" tIns="91425" rIns="91425" bIns="91425" anchor="t" anchorCtr="0">
             <a:spAutoFit/>
           </a:bodyPr>
@@ -10600,6 +11072,18 @@
               </a:spcAft>
               <a:buNone/>
             </a:pPr>
+            <a:r>
+              <a:rPr lang="es-MX" sz="3120" dirty="0">
+                <a:solidFill>
+                  <a:schemeClr val="dk2"/>
+                </a:solidFill>
+                <a:latin typeface="Poppins SemiBold"/>
+                <a:ea typeface="Poppins SemiBold"/>
+                <a:cs typeface="Poppins SemiBold"/>
+                <a:sym typeface="Poppins SemiBold"/>
+              </a:rPr>
+              <a:t>Enviar reporte al supervisor para aprobación final.</a:t>
+            </a:r>
             <a:endParaRPr sz="3120" dirty="0">
               <a:solidFill>
                 <a:schemeClr val="dk2"/>
@@ -10612,109 +11096,9 @@
           </a:p>
         </p:txBody>
       </p:sp>
-      <p:sp>
-        <p:nvSpPr>
-          <p:cNvPr id="151" name="Google Shape;151;p15"/>
-          <p:cNvSpPr txBox="1"/>
-          <p:nvPr/>
-        </p:nvSpPr>
-        <p:spPr>
-          <a:xfrm>
-            <a:off x="4158375" y="16754925"/>
-            <a:ext cx="10342800" cy="664767"/>
-          </a:xfrm>
-          <a:prstGeom prst="rect">
-            <a:avLst/>
-          </a:prstGeom>
-          <a:noFill/>
-          <a:ln>
-            <a:noFill/>
-          </a:ln>
-        </p:spPr>
-        <p:txBody>
-          <a:bodyPr spcFirstLastPara="1" wrap="square" lIns="91425" tIns="91425" rIns="91425" bIns="91425" anchor="t" anchorCtr="0">
-            <a:spAutoFit/>
-          </a:bodyPr>
-          <a:lstStyle/>
-          <a:p>
-            <a:pPr marL="0" lvl="0" indent="0" algn="l" rtl="0">
-              <a:lnSpc>
-                <a:spcPct val="100000"/>
-              </a:lnSpc>
-              <a:spcBef>
-                <a:spcPts val="0"/>
-              </a:spcBef>
-              <a:spcAft>
-                <a:spcPts val="0"/>
-              </a:spcAft>
-              <a:buClr>
-                <a:schemeClr val="dk1"/>
-              </a:buClr>
-              <a:buSzPts val="1100"/>
-              <a:buFont typeface="Arial"/>
-              <a:buNone/>
-            </a:pPr>
-            <a:endParaRPr sz="3120" dirty="0">
-              <a:solidFill>
-                <a:schemeClr val="dk2"/>
-              </a:solidFill>
-              <a:latin typeface="Poppins SemiBold"/>
-              <a:ea typeface="Poppins SemiBold"/>
-              <a:cs typeface="Poppins SemiBold"/>
-              <a:sym typeface="Poppins SemiBold"/>
-            </a:endParaRPr>
-          </a:p>
-        </p:txBody>
-      </p:sp>
-      <p:sp>
-        <p:nvSpPr>
-          <p:cNvPr id="152" name="Google Shape;152;p15"/>
-          <p:cNvSpPr/>
-          <p:nvPr/>
-        </p:nvSpPr>
-        <p:spPr>
-          <a:xfrm>
-            <a:off x="841200" y="20652225"/>
-            <a:ext cx="18108600" cy="4241700"/>
-          </a:xfrm>
-          <a:prstGeom prst="roundRect">
-            <a:avLst>
-              <a:gd name="adj" fmla="val 13941"/>
-            </a:avLst>
-          </a:prstGeom>
-          <a:noFill/>
-          <a:ln w="38100" cap="flat" cmpd="sng">
-            <a:solidFill>
-              <a:srgbClr val="F26F33"/>
-            </a:solidFill>
-            <a:prstDash val="solid"/>
-            <a:round/>
-            <a:headEnd type="none" w="sm" len="sm"/>
-            <a:tailEnd type="none" w="sm" len="sm"/>
-          </a:ln>
-        </p:spPr>
-        <p:txBody>
-          <a:bodyPr spcFirstLastPara="1" wrap="square" lIns="91425" tIns="91425" rIns="91425" bIns="91425" anchor="ctr" anchorCtr="0">
-            <a:noAutofit/>
-          </a:bodyPr>
-          <a:lstStyle/>
-          <a:p>
-            <a:pPr marL="0" lvl="0" indent="0" algn="ctr" rtl="0">
-              <a:spcBef>
-                <a:spcPts val="0"/>
-              </a:spcBef>
-              <a:spcAft>
-                <a:spcPts val="0"/>
-              </a:spcAft>
-              <a:buNone/>
-            </a:pPr>
-            <a:endParaRPr sz="2100"/>
-          </a:p>
-        </p:txBody>
-      </p:sp>
       <p:pic>
         <p:nvPicPr>
-          <p:cNvPr id="153" name="Google Shape;153;p15" title="paso.png"/>
+          <p:cNvPr id="153" name="var:descripcion_paso_7" title="paso.png"/>
           <p:cNvPicPr preferRelativeResize="0"/>
           <p:nvPr/>
         </p:nvPicPr>
@@ -10742,119 +11126,7 @@
       </p:pic>
       <p:sp>
         <p:nvSpPr>
-          <p:cNvPr id="154" name="Google Shape;154;p15"/>
-          <p:cNvSpPr txBox="1"/>
-          <p:nvPr/>
-        </p:nvSpPr>
-        <p:spPr>
-          <a:xfrm>
-            <a:off x="1719558" y="21232362"/>
-            <a:ext cx="1532400" cy="2876400"/>
-          </a:xfrm>
-          <a:prstGeom prst="rect">
-            <a:avLst/>
-          </a:prstGeom>
-          <a:noFill/>
-          <a:ln>
-            <a:noFill/>
-          </a:ln>
-        </p:spPr>
-        <p:txBody>
-          <a:bodyPr spcFirstLastPara="1" wrap="square" lIns="80600" tIns="80600" rIns="80600" bIns="80600" anchor="t" anchorCtr="0">
-            <a:spAutoFit/>
-          </a:bodyPr>
-          <a:lstStyle/>
-          <a:p>
-            <a:pPr marL="0" lvl="0" indent="0" algn="ctr" rtl="0">
-              <a:spcBef>
-                <a:spcPts val="0"/>
-              </a:spcBef>
-              <a:spcAft>
-                <a:spcPts val="0"/>
-              </a:spcAft>
-              <a:buNone/>
-            </a:pPr>
-            <a:r>
-              <a:rPr lang="en" sz="17629" dirty="0">
-                <a:solidFill>
-                  <a:srgbClr val="FFF0E6"/>
-                </a:solidFill>
-                <a:latin typeface="Montserrat ExtraBold"/>
-                <a:ea typeface="Montserrat ExtraBold"/>
-                <a:cs typeface="Montserrat ExtraBold"/>
-                <a:sym typeface="Montserrat ExtraBold"/>
-              </a:rPr>
-              <a:t>7</a:t>
-            </a:r>
-            <a:endParaRPr sz="17629" dirty="0">
-              <a:solidFill>
-                <a:srgbClr val="FFF0E6"/>
-              </a:solidFill>
-              <a:latin typeface="Montserrat ExtraBold"/>
-              <a:ea typeface="Montserrat ExtraBold"/>
-              <a:cs typeface="Montserrat ExtraBold"/>
-              <a:sym typeface="Montserrat ExtraBold"/>
-            </a:endParaRPr>
-          </a:p>
-        </p:txBody>
-      </p:sp>
-      <p:sp>
-        <p:nvSpPr>
-          <p:cNvPr id="155" name="Google Shape;155;p15"/>
-          <p:cNvSpPr txBox="1"/>
-          <p:nvPr/>
-        </p:nvSpPr>
-        <p:spPr>
-          <a:xfrm>
-            <a:off x="4158375" y="21480075"/>
-            <a:ext cx="11043600" cy="664767"/>
-          </a:xfrm>
-          <a:prstGeom prst="rect">
-            <a:avLst/>
-          </a:prstGeom>
-          <a:noFill/>
-          <a:ln>
-            <a:noFill/>
-          </a:ln>
-        </p:spPr>
-        <p:txBody>
-          <a:bodyPr spcFirstLastPara="1" wrap="square" lIns="91425" tIns="91425" rIns="91425" bIns="91425" anchor="t" anchorCtr="0">
-            <a:spAutoFit/>
-          </a:bodyPr>
-          <a:lstStyle/>
-          <a:p>
-            <a:pPr marL="0" lvl="0" indent="0" algn="l" rtl="0">
-              <a:lnSpc>
-                <a:spcPct val="100000"/>
-              </a:lnSpc>
-              <a:spcBef>
-                <a:spcPts val="0"/>
-              </a:spcBef>
-              <a:spcAft>
-                <a:spcPts val="0"/>
-              </a:spcAft>
-              <a:buClr>
-                <a:schemeClr val="dk1"/>
-              </a:buClr>
-              <a:buSzPts val="1100"/>
-              <a:buFont typeface="Arial"/>
-              <a:buNone/>
-            </a:pPr>
-            <a:endParaRPr sz="3120" dirty="0">
-              <a:solidFill>
-                <a:schemeClr val="dk2"/>
-              </a:solidFill>
-              <a:latin typeface="Poppins SemiBold"/>
-              <a:ea typeface="Poppins SemiBold"/>
-              <a:cs typeface="Poppins SemiBold"/>
-              <a:sym typeface="Poppins SemiBold"/>
-            </a:endParaRPr>
-          </a:p>
-        </p:txBody>
-      </p:sp>
-      <p:sp>
-        <p:nvSpPr>
-          <p:cNvPr id="156" name="Google Shape;156;p15"/>
+          <p:cNvPr id="156" name="var:descripcion_paso_3"/>
           <p:cNvSpPr/>
           <p:nvPr/>
         </p:nvSpPr>
@@ -10922,7 +11194,7 @@
       </p:sp>
       <p:sp>
         <p:nvSpPr>
-          <p:cNvPr id="157" name="Google Shape;157;p15"/>
+          <p:cNvPr id="157" name="var:descripcion_paso_3"/>
           <p:cNvSpPr/>
           <p:nvPr/>
         </p:nvSpPr>
@@ -10990,7 +11262,7 @@
       </p:sp>
       <p:sp>
         <p:nvSpPr>
-          <p:cNvPr id="158" name="Google Shape;158;p15"/>
+          <p:cNvPr id="158" name="var:descripcion_paso_3"/>
           <p:cNvSpPr/>
           <p:nvPr/>
         </p:nvSpPr>
@@ -11058,7 +11330,7 @@
       </p:sp>
       <p:sp>
         <p:nvSpPr>
-          <p:cNvPr id="159" name="Google Shape;159;p15"/>
+          <p:cNvPr id="159" name="var:descripcion_paso_4"/>
           <p:cNvSpPr/>
           <p:nvPr/>
         </p:nvSpPr>
@@ -11126,149 +11398,13 @@
       </p:sp>
       <p:sp>
         <p:nvSpPr>
-          <p:cNvPr id="160" name="Google Shape;160;p15"/>
+          <p:cNvPr id="160" name="var:descripcion_paso_5"/>
           <p:cNvSpPr/>
           <p:nvPr/>
         </p:nvSpPr>
         <p:spPr>
           <a:xfrm>
             <a:off x="15796225" y="11633025"/>
-            <a:ext cx="2876400" cy="2876400"/>
-          </a:xfrm>
-          <a:prstGeom prst="roundRect">
-            <a:avLst>
-              <a:gd name="adj" fmla="val 16667"/>
-            </a:avLst>
-          </a:prstGeom>
-          <a:solidFill>
-            <a:schemeClr val="lt2"/>
-          </a:solidFill>
-          <a:ln w="9525" cap="flat" cmpd="sng">
-            <a:solidFill>
-              <a:schemeClr val="dk2"/>
-            </a:solidFill>
-            <a:prstDash val="solid"/>
-            <a:round/>
-            <a:headEnd type="none" w="sm" len="sm"/>
-            <a:tailEnd type="none" w="sm" len="sm"/>
-          </a:ln>
-        </p:spPr>
-        <p:txBody>
-          <a:bodyPr spcFirstLastPara="1" wrap="square" lIns="91425" tIns="91425" rIns="91425" bIns="91425" anchor="ctr" anchorCtr="0">
-            <a:noAutofit/>
-          </a:bodyPr>
-          <a:lstStyle/>
-          <a:p>
-            <a:pPr marL="0" lvl="0" indent="0" algn="ctr" rtl="0">
-              <a:spcBef>
-                <a:spcPts val="0"/>
-              </a:spcBef>
-              <a:spcAft>
-                <a:spcPts val="0"/>
-              </a:spcAft>
-              <a:buNone/>
-            </a:pPr>
-            <a:r>
-              <a:rPr lang="en" sz="2100"/>
-              <a:t>ESPACIO PARA</a:t>
-            </a:r>
-            <a:endParaRPr sz="2100"/>
-          </a:p>
-          <a:p>
-            <a:pPr marL="0" lvl="0" indent="0" algn="ctr" rtl="0">
-              <a:spcBef>
-                <a:spcPts val="0"/>
-              </a:spcBef>
-              <a:spcAft>
-                <a:spcPts val="0"/>
-              </a:spcAft>
-              <a:buNone/>
-            </a:pPr>
-            <a:r>
-              <a:rPr lang="en" sz="2100"/>
-              <a:t>IMAGEN/GRÁFICO</a:t>
-            </a:r>
-            <a:endParaRPr sz="2100"/>
-          </a:p>
-        </p:txBody>
-      </p:sp>
-      <p:sp>
-        <p:nvSpPr>
-          <p:cNvPr id="161" name="Google Shape;161;p15"/>
-          <p:cNvSpPr/>
-          <p:nvPr/>
-        </p:nvSpPr>
-        <p:spPr>
-          <a:xfrm>
-            <a:off x="15796225" y="16323225"/>
-            <a:ext cx="2876400" cy="2876400"/>
-          </a:xfrm>
-          <a:prstGeom prst="roundRect">
-            <a:avLst>
-              <a:gd name="adj" fmla="val 16667"/>
-            </a:avLst>
-          </a:prstGeom>
-          <a:solidFill>
-            <a:schemeClr val="lt2"/>
-          </a:solidFill>
-          <a:ln w="9525" cap="flat" cmpd="sng">
-            <a:solidFill>
-              <a:schemeClr val="dk2"/>
-            </a:solidFill>
-            <a:prstDash val="solid"/>
-            <a:round/>
-            <a:headEnd type="none" w="sm" len="sm"/>
-            <a:tailEnd type="none" w="sm" len="sm"/>
-          </a:ln>
-        </p:spPr>
-        <p:txBody>
-          <a:bodyPr spcFirstLastPara="1" wrap="square" lIns="91425" tIns="91425" rIns="91425" bIns="91425" anchor="ctr" anchorCtr="0">
-            <a:noAutofit/>
-          </a:bodyPr>
-          <a:lstStyle/>
-          <a:p>
-            <a:pPr marL="0" lvl="0" indent="0" algn="ctr" rtl="0">
-              <a:spcBef>
-                <a:spcPts val="0"/>
-              </a:spcBef>
-              <a:spcAft>
-                <a:spcPts val="0"/>
-              </a:spcAft>
-              <a:buNone/>
-            </a:pPr>
-            <a:r>
-              <a:rPr lang="en" sz="2100"/>
-              <a:t>ESPACIO PARA</a:t>
-            </a:r>
-            <a:endParaRPr sz="2100"/>
-          </a:p>
-          <a:p>
-            <a:pPr marL="0" lvl="0" indent="0" algn="ctr" rtl="0">
-              <a:spcBef>
-                <a:spcPts val="0"/>
-              </a:spcBef>
-              <a:spcAft>
-                <a:spcPts val="0"/>
-              </a:spcAft>
-              <a:buNone/>
-            </a:pPr>
-            <a:r>
-              <a:rPr lang="en" sz="2100"/>
-              <a:t>IMAGEN/GRÁFICO</a:t>
-            </a:r>
-            <a:endParaRPr sz="2100"/>
-          </a:p>
-        </p:txBody>
-      </p:sp>
-      <p:sp>
-        <p:nvSpPr>
-          <p:cNvPr id="162" name="Google Shape;162;p15"/>
-          <p:cNvSpPr/>
-          <p:nvPr/>
-        </p:nvSpPr>
-        <p:spPr>
-          <a:xfrm>
-            <a:off x="15796225" y="21334875"/>
             <a:ext cx="2876400" cy="2876400"/>
           </a:xfrm>
           <a:prstGeom prst="roundRect">

</xml_diff>